<commit_message>
Correct PFP part 2 extra card against the full 2017 consensus text
Checked the card against the full Powers 2017 consensus PDF: the force
example now follows Statement 1.2b.2 (people with PFP show lower, not
higher, joint reaction force, and load spikes are not in the paper), the
contact-area example follows 1.1a/1.1a.2, the pain mechanism follows
Statement 1 (bone pressure, stated as an assumption) and the note states
that no prospective study links stress to PFP and that pain also involves
sensitisation.

Co-Authored-By: Claude Opus 5.5 <noreply@anthropic.com>
Claude-Session: https://claude.ai/code/session_01ShtY7D75A5srLcHNhwusCN
</commit_message>
<xml_diff>
--- a/content/pfp-runners-part2-why/adobe-express/pfp-runners-part2-why-express.pptx
+++ b/content/pfp-runners-part2-why/adobe-express/pfp-runners-part2-why-express.pptx
@@ -102,7 +102,7 @@
         </p:nvSpPr>
         <p:spPr>
           <a:xfrm>
-            <a:off x="914400" y="3329880"/>
+            <a:off x="914400" y="3291780"/>
             <a:ext cx="8458200" cy="1958280"/>
           </a:xfrm>
           <a:prstGeom prst="roundRect">
@@ -293,7 +293,7 @@
         </p:nvSpPr>
         <p:spPr>
           <a:xfrm>
-            <a:off x="2776984" y="3666684"/>
+            <a:off x="2776984" y="3628584"/>
             <a:ext cx="4732883" cy="638175"/>
           </a:xfrm>
           <a:prstGeom prst="rect">
@@ -352,7 +352,7 @@
         </p:nvSpPr>
         <p:spPr>
           <a:xfrm>
-            <a:off x="1929259" y="4360075"/>
+            <a:off x="1929259" y="4321975"/>
             <a:ext cx="6428482" cy="638175"/>
           </a:xfrm>
           <a:prstGeom prst="rect">
@@ -411,7 +411,7 @@
         </p:nvSpPr>
         <p:spPr>
           <a:xfrm>
-            <a:off x="2772817" y="5791843"/>
+            <a:off x="2772817" y="5677543"/>
             <a:ext cx="4741218" cy="552450"/>
           </a:xfrm>
           <a:prstGeom prst="rect">
@@ -464,14 +464,14 @@
       </p:sp>
       <p:sp>
         <p:nvSpPr>
-          <p:cNvPr id="9" name="텍스트: 무릎을 굽힌 채 버티는 부하가"/>
-          <p:cNvSpPr txBox="1"/>
-          <p:nvPr/>
-        </p:nvSpPr>
-        <p:spPr>
-          <a:xfrm>
-            <a:off x="2541984" y="6445931"/>
-            <a:ext cx="5203031" cy="409575"/>
+          <p:cNvPr id="9" name="텍스트: 무릎 펴는 근육이 크게 일할 때"/>
+          <p:cNvSpPr txBox="1"/>
+          <p:nvPr/>
+        </p:nvSpPr>
+        <p:spPr>
+          <a:xfrm>
+            <a:off x="2497336" y="6331631"/>
+            <a:ext cx="5292179" cy="409575"/>
           </a:xfrm>
           <a:prstGeom prst="rect">
             <a:avLst/>
@@ -508,7 +508,7 @@
                 <a:ea typeface="RCardnews W500" pitchFamily="34" charset="-127"/>
                 <a:cs typeface="RCardnews W500" pitchFamily="34" charset="-127"/>
               </a:rPr>
-              <a:t xml:space="preserve">무릎을 굽힌 채 버티는 부하가</a:t>
+              <a:t xml:space="preserve">무릎 펴는 근육이 크게 일할 때</a:t>
             </a:r>
             <a:endParaRPr lang="ko-KR" altLang="en-US" sz="2700" b="0" i="0" spc="-54" kern="0" dirty="0">
               <a:solidFill>
@@ -523,14 +523,14 @@
       </p:sp>
       <p:sp>
         <p:nvSpPr>
-          <p:cNvPr id="10" name="텍스트: 갑자기 늘 때"/>
-          <p:cNvSpPr txBox="1"/>
-          <p:nvPr/>
-        </p:nvSpPr>
-        <p:spPr>
-          <a:xfrm>
-            <a:off x="3711178" y="6925901"/>
-            <a:ext cx="2864495" cy="409575"/>
+          <p:cNvPr id="10" name="텍스트: 예: 상체를 꼿꼿이 세우고 달리기"/>
+          <p:cNvSpPr txBox="1"/>
+          <p:nvPr/>
+        </p:nvSpPr>
+        <p:spPr>
+          <a:xfrm>
+            <a:off x="2339876" y="6811601"/>
+            <a:ext cx="5607248" cy="409575"/>
           </a:xfrm>
           <a:prstGeom prst="rect">
             <a:avLst/>
@@ -567,7 +567,7 @@
                 <a:ea typeface="RCardnews W500" pitchFamily="34" charset="-127"/>
                 <a:cs typeface="RCardnews W500" pitchFamily="34" charset="-127"/>
               </a:rPr>
-              <a:t xml:space="preserve">갑자기 늘 때</a:t>
+              <a:t xml:space="preserve">예: 상체를 꼿꼿이 세우고 달리기</a:t>
             </a:r>
             <a:endParaRPr lang="ko-KR" altLang="en-US" sz="2700" b="0" i="0" spc="-54" kern="0" dirty="0">
               <a:solidFill>
@@ -588,7 +588,7 @@
         </p:nvSpPr>
         <p:spPr>
           <a:xfrm>
-            <a:off x="2569369" y="7708005"/>
+            <a:off x="2569369" y="7555605"/>
             <a:ext cx="5148114" cy="552450"/>
           </a:xfrm>
           <a:prstGeom prst="rect">
@@ -641,14 +641,14 @@
       </p:sp>
       <p:sp>
         <p:nvSpPr>
-          <p:cNvPr id="12" name="텍스트: 무릎뼈 정렬, 허벅지가 안으로"/>
-          <p:cNvSpPr txBox="1"/>
-          <p:nvPr/>
-        </p:nvSpPr>
-        <p:spPr>
-          <a:xfrm>
-            <a:off x="2538710" y="8362093"/>
-            <a:ext cx="5209580" cy="409575"/>
+          <p:cNvPr id="12" name="텍스트: 무릎뼈가 바깥으로 치우치거나"/>
+          <p:cNvSpPr txBox="1"/>
+          <p:nvPr/>
+        </p:nvSpPr>
+        <p:spPr>
+          <a:xfrm>
+            <a:off x="2476798" y="8209693"/>
+            <a:ext cx="5333256" cy="409575"/>
           </a:xfrm>
           <a:prstGeom prst="rect">
             <a:avLst/>
@@ -685,7 +685,7 @@
                 <a:ea typeface="RCardnews W500" pitchFamily="34" charset="-127"/>
                 <a:cs typeface="RCardnews W500" pitchFamily="34" charset="-127"/>
               </a:rPr>
-              <a:t xml:space="preserve">무릎뼈 정렬, 허벅지가 안으로</a:t>
+              <a:t xml:space="preserve">무릎뼈가 바깥으로 치우치거나</a:t>
             </a:r>
             <a:endParaRPr lang="ko-KR" altLang="en-US" sz="2700" b="0" i="0" spc="-54" kern="0" dirty="0">
               <a:solidFill>
@@ -700,14 +700,14 @@
       </p:sp>
       <p:sp>
         <p:nvSpPr>
-          <p:cNvPr id="13" name="텍스트: 모이는 움직임 등"/>
-          <p:cNvSpPr txBox="1"/>
-          <p:nvPr/>
-        </p:nvSpPr>
-        <p:spPr>
-          <a:xfrm>
-            <a:off x="3402657" y="8842063"/>
-            <a:ext cx="3481685" cy="409575"/>
+          <p:cNvPr id="13" name="텍스트: 허벅지가 안으로 돌아갈 때"/>
+          <p:cNvSpPr txBox="1"/>
+          <p:nvPr/>
+        </p:nvSpPr>
+        <p:spPr>
+          <a:xfrm>
+            <a:off x="2740819" y="8689663"/>
+            <a:ext cx="4805214" cy="409575"/>
           </a:xfrm>
           <a:prstGeom prst="rect">
             <a:avLst/>
@@ -744,7 +744,7 @@
                 <a:ea typeface="RCardnews W500" pitchFamily="34" charset="-127"/>
                 <a:cs typeface="RCardnews W500" pitchFamily="34" charset="-127"/>
               </a:rPr>
-              <a:t xml:space="preserve">모이는 움직임 등</a:t>
+              <a:t xml:space="preserve">허벅지가 안으로 돌아갈 때</a:t>
             </a:r>
             <a:endParaRPr lang="ko-KR" altLang="en-US" sz="2700" b="0" i="0" spc="-54" kern="0" dirty="0">
               <a:solidFill>
@@ -759,14 +759,14 @@
       </p:sp>
       <p:sp>
         <p:nvSpPr>
-          <p:cNvPr id="14" name="텍스트: 견딜 수 있는 수준을 넘는 압박이 반복되면"/>
-          <p:cNvSpPr txBox="1"/>
-          <p:nvPr/>
-        </p:nvSpPr>
-        <p:spPr>
-          <a:xfrm>
-            <a:off x="1038969" y="9755231"/>
-            <a:ext cx="8209062" cy="504825"/>
+          <p:cNvPr id="14" name="텍스트: 과한 압박이 반복되면 무릎뼈 속 압력이"/>
+          <p:cNvSpPr txBox="1"/>
+          <p:nvPr/>
+        </p:nvSpPr>
+        <p:spPr>
+          <a:xfrm>
+            <a:off x="1282005" y="9564731"/>
+            <a:ext cx="7722989" cy="504825"/>
           </a:xfrm>
           <a:prstGeom prst="rect">
             <a:avLst/>
@@ -803,7 +803,7 @@
                 <a:ea typeface="RCardnews W500" pitchFamily="34" charset="-127"/>
                 <a:cs typeface="RCardnews W500" pitchFamily="34" charset="-127"/>
               </a:rPr>
-              <a:t xml:space="preserve">견딜 수 있는 수준을 넘는 압박이 반복되면</a:t>
+              <a:t xml:space="preserve">과한 압박이 반복되면 무릎뼈 속 압력이</a:t>
             </a:r>
             <a:endParaRPr lang="ko-KR" altLang="en-US" sz="3300" b="0" i="0" spc="-66" kern="0" dirty="0">
               <a:solidFill>
@@ -818,14 +818,14 @@
       </p:sp>
       <p:sp>
         <p:nvSpPr>
-          <p:cNvPr id="15" name="텍스트: 주변 조직이 예민해져 아플 수 있습니다."/>
-          <p:cNvSpPr txBox="1"/>
-          <p:nvPr/>
-        </p:nvSpPr>
-        <p:spPr>
-          <a:xfrm>
-            <a:off x="1223516" y="10350246"/>
-            <a:ext cx="7839819" cy="504825"/>
+          <p:cNvPr id="15" name="텍스트: 올라 아플 수 있다고 추정합니다."/>
+          <p:cNvSpPr txBox="1"/>
+          <p:nvPr/>
+        </p:nvSpPr>
+        <p:spPr>
+          <a:xfrm>
+            <a:off x="1843832" y="10159746"/>
+            <a:ext cx="6599337" cy="504825"/>
           </a:xfrm>
           <a:prstGeom prst="rect">
             <a:avLst/>
@@ -862,7 +862,7 @@
                 <a:ea typeface="RCardnews W500" pitchFamily="34" charset="-127"/>
                 <a:cs typeface="RCardnews W500" pitchFamily="34" charset="-127"/>
               </a:rPr>
-              <a:t xml:space="preserve">주변 조직이 예민해져 아플 수 있습니다.</a:t>
+              <a:t xml:space="preserve">올라 아플 수 있다고 추정합니다.</a:t>
             </a:r>
             <a:endParaRPr lang="ko-KR" altLang="en-US" sz="3300" b="0" i="0" spc="-66" kern="0" dirty="0">
               <a:solidFill>
@@ -877,14 +877,14 @@
       </p:sp>
       <p:sp>
         <p:nvSpPr>
-          <p:cNvPr id="16" name="텍스트: 어느 조직이 아픈지는 아직 정확히 모릅니다"/>
-          <p:cNvSpPr txBox="1"/>
-          <p:nvPr/>
-        </p:nvSpPr>
-        <p:spPr>
-          <a:xfrm>
-            <a:off x="1571476" y="11083564"/>
-            <a:ext cx="7143899" cy="409575"/>
+          <p:cNvPr id="16" name="텍스트: 아직 가설이며, 통증에는 신경이 예민해지는 "/>
+          <p:cNvSpPr txBox="1"/>
+          <p:nvPr/>
+        </p:nvSpPr>
+        <p:spPr>
+          <a:xfrm>
+            <a:off x="1369368" y="10874014"/>
+            <a:ext cx="7548116" cy="409575"/>
           </a:xfrm>
           <a:prstGeom prst="rect">
             <a:avLst/>
@@ -921,7 +921,66 @@
                 <a:ea typeface="RCardnews W500" pitchFamily="34" charset="-127"/>
                 <a:cs typeface="RCardnews W500" pitchFamily="34" charset="-127"/>
               </a:rPr>
-              <a:t xml:space="preserve">어느 조직이 아픈지는 아직 정확히 모릅니다</a:t>
+              <a:t xml:space="preserve">아직 가설이며, 통증에는 신경이 예민해지는 등</a:t>
+            </a:r>
+            <a:endParaRPr lang="ko-KR" altLang="en-US" sz="2700" b="0" i="0" spc="-54" kern="0" dirty="0">
+              <a:solidFill>
+                <a:srgbClr val="5E6570"/>
+              </a:solidFill>
+              <a:latin typeface="RCardnews W500" pitchFamily="34" charset="-127"/>
+              <a:ea typeface="RCardnews W500" pitchFamily="34" charset="-127"/>
+              <a:cs typeface="RCardnews W500" pitchFamily="34" charset="-127"/>
+            </a:endParaRPr>
+          </a:p>
+        </p:txBody>
+      </p:sp>
+      <p:sp>
+        <p:nvSpPr>
+          <p:cNvPr id="17" name="텍스트: 다른 요인도 함께 작용합니다"/>
+          <p:cNvSpPr txBox="1"/>
+          <p:nvPr/>
+        </p:nvSpPr>
+        <p:spPr>
+          <a:xfrm>
+            <a:off x="2586484" y="11353985"/>
+            <a:ext cx="5113883" cy="409575"/>
+          </a:xfrm>
+          <a:prstGeom prst="rect">
+            <a:avLst/>
+          </a:prstGeom>
+          <a:noFill/>
+          <a:ln>
+            <a:noFill/>
+          </a:ln>
+        </p:spPr>
+        <p:txBody>
+          <a:bodyPr vert="horz" wrap="none" lIns="0" tIns="0" rIns="0" bIns="0" rtlCol="0" anchor="ctr" anchorCtr="0">
+            <a:noAutofit/>
+          </a:bodyPr>
+          <a:lstStyle/>
+          <a:p>
+            <a:pPr algn="ctr">
+              <a:lnSpc>
+                <a:spcPct val="100000"/>
+              </a:lnSpc>
+              <a:spcBef>
+                <a:spcPts val="0"/>
+              </a:spcBef>
+              <a:spcAft>
+                <a:spcPts val="0"/>
+              </a:spcAft>
+              <a:buNone/>
+            </a:pPr>
+            <a:r>
+              <a:rPr lang="ko-KR" altLang="en-US" sz="2700" b="0" i="0" spc="-54" kern="0" dirty="0">
+                <a:solidFill>
+                  <a:srgbClr val="5E6570"/>
+                </a:solidFill>
+                <a:latin typeface="RCardnews W500" pitchFamily="34" charset="-127"/>
+                <a:ea typeface="RCardnews W500" pitchFamily="34" charset="-127"/>
+                <a:cs typeface="RCardnews W500" pitchFamily="34" charset="-127"/>
+              </a:rPr>
+              <a:t xml:space="preserve">다른 요인도 함께 작용합니다</a:t>
             </a:r>
             <a:endParaRPr lang="ko-KR" altLang="en-US" sz="2700" b="0" i="0" spc="-54" kern="0" dirty="0">
               <a:solidFill>

</xml_diff>

<commit_message>
Add user-supplied contact-area figure to PFP part 2 extra card
The figure's source and licence are not yet confirmed and are flagged
in the asset manifest and QA report as a pre-posting check.

Co-Authored-By: Claude Opus 5.5 <noreply@anthropic.com>
Claude-Session: https://claude.ai/code/session_01ShtY7D75A5srLcHNhwusCN
</commit_message>
<xml_diff>
--- a/content/pfp-runners-part2-why/adobe-express/pfp-runners-part2-why-express.pptx
+++ b/content/pfp-runners-part2-why/adobe-express/pfp-runners-part2-why-express.pptx
@@ -102,12 +102,12 @@
         </p:nvSpPr>
         <p:spPr>
           <a:xfrm>
-            <a:off x="914400" y="3291780"/>
-            <a:ext cx="8458200" cy="1958280"/>
+            <a:off x="914400" y="3253680"/>
+            <a:ext cx="8458200" cy="1188690"/>
           </a:xfrm>
           <a:prstGeom prst="roundRect">
             <a:avLst>
-              <a:gd name="adj" fmla="val 9728"/>
+              <a:gd name="adj" fmla="val 16026"/>
             </a:avLst>
           </a:prstGeom>
           <a:solidFill>
@@ -125,9 +125,33 @@
           </a:p>
         </p:txBody>
       </p:sp>
-      <p:sp>
-        <p:nvSpPr>
-          <p:cNvPr id="3" name="B01 프레임"/>
+      <p:pic>
+        <p:nvPicPr>
+          <p:cNvPr id="3" name="사진" descr="무릎 굽힘 각도별 무릎뼈와 넙다리뼈의 접촉 부위"/>
+          <p:cNvPicPr>
+            <a:picLocks noChangeAspect="1"/>
+          </p:cNvPicPr>
+          <p:nvPr/>
+        </p:nvPicPr>
+        <p:blipFill>
+          <a:blip r:embed="rId2"/>
+          <a:stretch>
+            <a:fillRect/>
+          </a:stretch>
+        </p:blipFill>
+        <p:spPr>
+          <a:xfrm>
+            <a:off x="1619250" y="4785271"/>
+            <a:ext cx="7048500" cy="4238625"/>
+          </a:xfrm>
+          <a:prstGeom prst="rect">
+            <a:avLst/>
+          </a:prstGeom>
+        </p:spPr>
+      </p:pic>
+      <p:sp>
+        <p:nvSpPr>
+          <p:cNvPr id="4" name="B01 프레임"/>
           <p:cNvSpPr/>
           <p:nvPr/>
         </p:nvSpPr>
@@ -158,7 +182,7 @@
       </p:sp>
       <p:sp>
         <p:nvSpPr>
-          <p:cNvPr id="4" name="텍스트: 무릎 앞 통증,"/>
+          <p:cNvPr id="5" name="텍스트: 무릎 앞 통증,"/>
           <p:cNvSpPr txBox="1"/>
           <p:nvPr/>
         </p:nvSpPr>
@@ -217,7 +241,7 @@
       </p:sp>
       <p:sp>
         <p:nvSpPr>
-          <p:cNvPr id="5" name="텍스트: 왜 생길까요?"/>
+          <p:cNvPr id="6" name="텍스트: 왜 생길까요?"/>
           <p:cNvSpPr txBox="1"/>
           <p:nvPr/>
         </p:nvSpPr>
@@ -287,14 +311,14 @@
       </p:sp>
       <p:sp>
         <p:nvSpPr>
-          <p:cNvPr id="6" name="텍스트: 무릎뼈 관절 압박"/>
+          <p:cNvPr id="7" name="텍스트: 압박 = 누르는 힘 ÷ 닿는 면적"/>
           <p:cNvSpPr txBox="1"/>
           <p:nvPr/>
         </p:nvSpPr>
         <p:spPr>
           <a:xfrm>
-            <a:off x="2776984" y="3628584"/>
-            <a:ext cx="4732883" cy="638175"/>
+            <a:off x="1387822" y="3552384"/>
+            <a:ext cx="7511355" cy="638175"/>
           </a:xfrm>
           <a:prstGeom prst="rect">
             <a:avLst/>
@@ -331,7 +355,7 @@
                 <a:ea typeface="RCardnews W800" pitchFamily="34" charset="-127"/>
                 <a:cs typeface="RCardnews W800" pitchFamily="34" charset="-127"/>
               </a:rPr>
-              <a:t xml:space="preserve">무릎뼈 관절 압박</a:t>
+              <a:t xml:space="preserve">압박 = 누르는 힘 ÷ 닿는 면적</a:t>
             </a:r>
             <a:endParaRPr lang="ko-KR" altLang="en-US" sz="4200" b="0" i="0" spc="-126" kern="0" dirty="0">
               <a:solidFill>
@@ -346,132 +370,14 @@
       </p:sp>
       <p:sp>
         <p:nvSpPr>
-          <p:cNvPr id="7" name="텍스트: = 누르는 힘 ÷ 닿는 면적"/>
+          <p:cNvPr id="8" name="텍스트: 무릎을 굽히는 각도에 따라 닿는 자리와 면적"/>
           <p:cNvSpPr txBox="1"/>
           <p:nvPr/>
         </p:nvSpPr>
         <p:spPr>
           <a:xfrm>
-            <a:off x="1929259" y="4321975"/>
-            <a:ext cx="6428482" cy="638175"/>
-          </a:xfrm>
-          <a:prstGeom prst="rect">
-            <a:avLst/>
-          </a:prstGeom>
-          <a:noFill/>
-          <a:ln>
-            <a:noFill/>
-          </a:ln>
-        </p:spPr>
-        <p:txBody>
-          <a:bodyPr vert="horz" wrap="none" lIns="0" tIns="0" rIns="0" bIns="0" rtlCol="0" anchor="ctr" anchorCtr="0">
-            <a:noAutofit/>
-          </a:bodyPr>
-          <a:lstStyle/>
-          <a:p>
-            <a:pPr algn="ctr">
-              <a:lnSpc>
-                <a:spcPct val="100000"/>
-              </a:lnSpc>
-              <a:spcBef>
-                <a:spcPts val="0"/>
-              </a:spcBef>
-              <a:spcAft>
-                <a:spcPts val="0"/>
-              </a:spcAft>
-              <a:buNone/>
-            </a:pPr>
-            <a:r>
-              <a:rPr lang="ko-KR" altLang="en-US" sz="4200" b="0" i="0" spc="-126" kern="0" dirty="0">
-                <a:solidFill>
-                  <a:srgbClr val="121416"/>
-                </a:solidFill>
-                <a:latin typeface="RCardnews W800" pitchFamily="34" charset="-127"/>
-                <a:ea typeface="RCardnews W800" pitchFamily="34" charset="-127"/>
-                <a:cs typeface="RCardnews W800" pitchFamily="34" charset="-127"/>
-              </a:rPr>
-              <a:t xml:space="preserve">= 누르는 힘 ÷ 닿는 면적</a:t>
-            </a:r>
-            <a:endParaRPr lang="ko-KR" altLang="en-US" sz="4200" b="0" i="0" spc="-126" kern="0" dirty="0">
-              <a:solidFill>
-                <a:srgbClr val="121416"/>
-              </a:solidFill>
-              <a:latin typeface="RCardnews W800" pitchFamily="34" charset="-127"/>
-              <a:ea typeface="RCardnews W800" pitchFamily="34" charset="-127"/>
-              <a:cs typeface="RCardnews W800" pitchFamily="34" charset="-127"/>
-            </a:endParaRPr>
-          </a:p>
-        </p:txBody>
-      </p:sp>
-      <p:sp>
-        <p:nvSpPr>
-          <p:cNvPr id="8" name="텍스트: 누르는 힘이 커질 때"/>
-          <p:cNvSpPr txBox="1"/>
-          <p:nvPr/>
-        </p:nvSpPr>
-        <p:spPr>
-          <a:xfrm>
-            <a:off x="2772817" y="5677543"/>
-            <a:ext cx="4741218" cy="552450"/>
-          </a:xfrm>
-          <a:prstGeom prst="rect">
-            <a:avLst/>
-          </a:prstGeom>
-          <a:noFill/>
-          <a:ln>
-            <a:noFill/>
-          </a:ln>
-        </p:spPr>
-        <p:txBody>
-          <a:bodyPr vert="horz" wrap="none" lIns="0" tIns="0" rIns="0" bIns="0" rtlCol="0" anchor="ctr" anchorCtr="0">
-            <a:noAutofit/>
-          </a:bodyPr>
-          <a:lstStyle/>
-          <a:p>
-            <a:pPr algn="ctr">
-              <a:lnSpc>
-                <a:spcPct val="100000"/>
-              </a:lnSpc>
-              <a:spcBef>
-                <a:spcPts val="0"/>
-              </a:spcBef>
-              <a:spcAft>
-                <a:spcPts val="0"/>
-              </a:spcAft>
-              <a:buNone/>
-            </a:pPr>
-            <a:r>
-              <a:rPr lang="ko-KR" altLang="en-US" sz="3600" b="0" i="0" spc="-108" kern="0" dirty="0">
-                <a:solidFill>
-                  <a:srgbClr val="121416"/>
-                </a:solidFill>
-                <a:latin typeface="RCardnews W800" pitchFamily="34" charset="-127"/>
-                <a:ea typeface="RCardnews W800" pitchFamily="34" charset="-127"/>
-                <a:cs typeface="RCardnews W800" pitchFamily="34" charset="-127"/>
-              </a:rPr>
-              <a:t xml:space="preserve">누르는 힘이 커질 때</a:t>
-            </a:r>
-            <a:endParaRPr lang="ko-KR" altLang="en-US" sz="3600" b="0" i="0" spc="-108" kern="0" dirty="0">
-              <a:solidFill>
-                <a:srgbClr val="121416"/>
-              </a:solidFill>
-              <a:latin typeface="RCardnews W800" pitchFamily="34" charset="-127"/>
-              <a:ea typeface="RCardnews W800" pitchFamily="34" charset="-127"/>
-              <a:cs typeface="RCardnews W800" pitchFamily="34" charset="-127"/>
-            </a:endParaRPr>
-          </a:p>
-        </p:txBody>
-      </p:sp>
-      <p:sp>
-        <p:nvSpPr>
-          <p:cNvPr id="9" name="텍스트: 무릎 펴는 근육이 크게 일할 때"/>
-          <p:cNvSpPr txBox="1"/>
-          <p:nvPr/>
-        </p:nvSpPr>
-        <p:spPr>
-          <a:xfrm>
-            <a:off x="2497336" y="6331631"/>
-            <a:ext cx="5292179" cy="409575"/>
+            <a:off x="710803" y="9206395"/>
+            <a:ext cx="8865245" cy="409575"/>
           </a:xfrm>
           <a:prstGeom prst="rect">
             <a:avLst/>
@@ -508,7 +414,7 @@
                 <a:ea typeface="RCardnews W500" pitchFamily="34" charset="-127"/>
                 <a:cs typeface="RCardnews W500" pitchFamily="34" charset="-127"/>
               </a:rPr>
-              <a:t xml:space="preserve">무릎 펴는 근육이 크게 일할 때</a:t>
+              <a:t xml:space="preserve">무릎을 굽히는 각도에 따라 닿는 자리와 면적이 바뀝니다</a:t>
             </a:r>
             <a:endParaRPr lang="ko-KR" altLang="en-US" sz="2700" b="0" i="0" spc="-54" kern="0" dirty="0">
               <a:solidFill>
@@ -523,249 +429,13 @@
       </p:sp>
       <p:sp>
         <p:nvSpPr>
-          <p:cNvPr id="10" name="텍스트: 예: 상체를 꼿꼿이 세우고 달리기"/>
+          <p:cNvPr id="9" name="텍스트: 과한 압박이 반복되면 무릎뼈 속 압력이"/>
           <p:cNvSpPr txBox="1"/>
           <p:nvPr/>
         </p:nvSpPr>
         <p:spPr>
           <a:xfrm>
-            <a:off x="2339876" y="6811601"/>
-            <a:ext cx="5607248" cy="409575"/>
-          </a:xfrm>
-          <a:prstGeom prst="rect">
-            <a:avLst/>
-          </a:prstGeom>
-          <a:noFill/>
-          <a:ln>
-            <a:noFill/>
-          </a:ln>
-        </p:spPr>
-        <p:txBody>
-          <a:bodyPr vert="horz" wrap="none" lIns="0" tIns="0" rIns="0" bIns="0" rtlCol="0" anchor="ctr" anchorCtr="0">
-            <a:noAutofit/>
-          </a:bodyPr>
-          <a:lstStyle/>
-          <a:p>
-            <a:pPr algn="ctr">
-              <a:lnSpc>
-                <a:spcPct val="100000"/>
-              </a:lnSpc>
-              <a:spcBef>
-                <a:spcPts val="0"/>
-              </a:spcBef>
-              <a:spcAft>
-                <a:spcPts val="0"/>
-              </a:spcAft>
-              <a:buNone/>
-            </a:pPr>
-            <a:r>
-              <a:rPr lang="ko-KR" altLang="en-US" sz="2700" b="0" i="0" spc="-54" kern="0" dirty="0">
-                <a:solidFill>
-                  <a:srgbClr val="5E6570"/>
-                </a:solidFill>
-                <a:latin typeface="RCardnews W500" pitchFamily="34" charset="-127"/>
-                <a:ea typeface="RCardnews W500" pitchFamily="34" charset="-127"/>
-                <a:cs typeface="RCardnews W500" pitchFamily="34" charset="-127"/>
-              </a:rPr>
-              <a:t xml:space="preserve">예: 상체를 꼿꼿이 세우고 달리기</a:t>
-            </a:r>
-            <a:endParaRPr lang="ko-KR" altLang="en-US" sz="2700" b="0" i="0" spc="-54" kern="0" dirty="0">
-              <a:solidFill>
-                <a:srgbClr val="5E6570"/>
-              </a:solidFill>
-              <a:latin typeface="RCardnews W500" pitchFamily="34" charset="-127"/>
-              <a:ea typeface="RCardnews W500" pitchFamily="34" charset="-127"/>
-              <a:cs typeface="RCardnews W500" pitchFamily="34" charset="-127"/>
-            </a:endParaRPr>
-          </a:p>
-        </p:txBody>
-      </p:sp>
-      <p:sp>
-        <p:nvSpPr>
-          <p:cNvPr id="11" name="텍스트: 닿는 면적이 작아질 때"/>
-          <p:cNvSpPr txBox="1"/>
-          <p:nvPr/>
-        </p:nvSpPr>
-        <p:spPr>
-          <a:xfrm>
-            <a:off x="2569369" y="7555605"/>
-            <a:ext cx="5148114" cy="552450"/>
-          </a:xfrm>
-          <a:prstGeom prst="rect">
-            <a:avLst/>
-          </a:prstGeom>
-          <a:noFill/>
-          <a:ln>
-            <a:noFill/>
-          </a:ln>
-        </p:spPr>
-        <p:txBody>
-          <a:bodyPr vert="horz" wrap="none" lIns="0" tIns="0" rIns="0" bIns="0" rtlCol="0" anchor="ctr" anchorCtr="0">
-            <a:noAutofit/>
-          </a:bodyPr>
-          <a:lstStyle/>
-          <a:p>
-            <a:pPr algn="ctr">
-              <a:lnSpc>
-                <a:spcPct val="100000"/>
-              </a:lnSpc>
-              <a:spcBef>
-                <a:spcPts val="0"/>
-              </a:spcBef>
-              <a:spcAft>
-                <a:spcPts val="0"/>
-              </a:spcAft>
-              <a:buNone/>
-            </a:pPr>
-            <a:r>
-              <a:rPr lang="ko-KR" altLang="en-US" sz="3600" b="0" i="0" spc="-108" kern="0" dirty="0">
-                <a:solidFill>
-                  <a:srgbClr val="121416"/>
-                </a:solidFill>
-                <a:latin typeface="RCardnews W800" pitchFamily="34" charset="-127"/>
-                <a:ea typeface="RCardnews W800" pitchFamily="34" charset="-127"/>
-                <a:cs typeface="RCardnews W800" pitchFamily="34" charset="-127"/>
-              </a:rPr>
-              <a:t xml:space="preserve">닿는 면적이 작아질 때</a:t>
-            </a:r>
-            <a:endParaRPr lang="ko-KR" altLang="en-US" sz="3600" b="0" i="0" spc="-108" kern="0" dirty="0">
-              <a:solidFill>
-                <a:srgbClr val="121416"/>
-              </a:solidFill>
-              <a:latin typeface="RCardnews W800" pitchFamily="34" charset="-127"/>
-              <a:ea typeface="RCardnews W800" pitchFamily="34" charset="-127"/>
-              <a:cs typeface="RCardnews W800" pitchFamily="34" charset="-127"/>
-            </a:endParaRPr>
-          </a:p>
-        </p:txBody>
-      </p:sp>
-      <p:sp>
-        <p:nvSpPr>
-          <p:cNvPr id="12" name="텍스트: 무릎뼈가 바깥으로 치우치거나"/>
-          <p:cNvSpPr txBox="1"/>
-          <p:nvPr/>
-        </p:nvSpPr>
-        <p:spPr>
-          <a:xfrm>
-            <a:off x="2476798" y="8209693"/>
-            <a:ext cx="5333256" cy="409575"/>
-          </a:xfrm>
-          <a:prstGeom prst="rect">
-            <a:avLst/>
-          </a:prstGeom>
-          <a:noFill/>
-          <a:ln>
-            <a:noFill/>
-          </a:ln>
-        </p:spPr>
-        <p:txBody>
-          <a:bodyPr vert="horz" wrap="none" lIns="0" tIns="0" rIns="0" bIns="0" rtlCol="0" anchor="ctr" anchorCtr="0">
-            <a:noAutofit/>
-          </a:bodyPr>
-          <a:lstStyle/>
-          <a:p>
-            <a:pPr algn="ctr">
-              <a:lnSpc>
-                <a:spcPct val="100000"/>
-              </a:lnSpc>
-              <a:spcBef>
-                <a:spcPts val="0"/>
-              </a:spcBef>
-              <a:spcAft>
-                <a:spcPts val="0"/>
-              </a:spcAft>
-              <a:buNone/>
-            </a:pPr>
-            <a:r>
-              <a:rPr lang="ko-KR" altLang="en-US" sz="2700" b="0" i="0" spc="-54" kern="0" dirty="0">
-                <a:solidFill>
-                  <a:srgbClr val="5E6570"/>
-                </a:solidFill>
-                <a:latin typeface="RCardnews W500" pitchFamily="34" charset="-127"/>
-                <a:ea typeface="RCardnews W500" pitchFamily="34" charset="-127"/>
-                <a:cs typeface="RCardnews W500" pitchFamily="34" charset="-127"/>
-              </a:rPr>
-              <a:t xml:space="preserve">무릎뼈가 바깥으로 치우치거나</a:t>
-            </a:r>
-            <a:endParaRPr lang="ko-KR" altLang="en-US" sz="2700" b="0" i="0" spc="-54" kern="0" dirty="0">
-              <a:solidFill>
-                <a:srgbClr val="5E6570"/>
-              </a:solidFill>
-              <a:latin typeface="RCardnews W500" pitchFamily="34" charset="-127"/>
-              <a:ea typeface="RCardnews W500" pitchFamily="34" charset="-127"/>
-              <a:cs typeface="RCardnews W500" pitchFamily="34" charset="-127"/>
-            </a:endParaRPr>
-          </a:p>
-        </p:txBody>
-      </p:sp>
-      <p:sp>
-        <p:nvSpPr>
-          <p:cNvPr id="13" name="텍스트: 허벅지가 안으로 돌아갈 때"/>
-          <p:cNvSpPr txBox="1"/>
-          <p:nvPr/>
-        </p:nvSpPr>
-        <p:spPr>
-          <a:xfrm>
-            <a:off x="2740819" y="8689663"/>
-            <a:ext cx="4805214" cy="409575"/>
-          </a:xfrm>
-          <a:prstGeom prst="rect">
-            <a:avLst/>
-          </a:prstGeom>
-          <a:noFill/>
-          <a:ln>
-            <a:noFill/>
-          </a:ln>
-        </p:spPr>
-        <p:txBody>
-          <a:bodyPr vert="horz" wrap="none" lIns="0" tIns="0" rIns="0" bIns="0" rtlCol="0" anchor="ctr" anchorCtr="0">
-            <a:noAutofit/>
-          </a:bodyPr>
-          <a:lstStyle/>
-          <a:p>
-            <a:pPr algn="ctr">
-              <a:lnSpc>
-                <a:spcPct val="100000"/>
-              </a:lnSpc>
-              <a:spcBef>
-                <a:spcPts val="0"/>
-              </a:spcBef>
-              <a:spcAft>
-                <a:spcPts val="0"/>
-              </a:spcAft>
-              <a:buNone/>
-            </a:pPr>
-            <a:r>
-              <a:rPr lang="ko-KR" altLang="en-US" sz="2700" b="0" i="0" spc="-54" kern="0" dirty="0">
-                <a:solidFill>
-                  <a:srgbClr val="5E6570"/>
-                </a:solidFill>
-                <a:latin typeface="RCardnews W500" pitchFamily="34" charset="-127"/>
-                <a:ea typeface="RCardnews W500" pitchFamily="34" charset="-127"/>
-                <a:cs typeface="RCardnews W500" pitchFamily="34" charset="-127"/>
-              </a:rPr>
-              <a:t xml:space="preserve">허벅지가 안으로 돌아갈 때</a:t>
-            </a:r>
-            <a:endParaRPr lang="ko-KR" altLang="en-US" sz="2700" b="0" i="0" spc="-54" kern="0" dirty="0">
-              <a:solidFill>
-                <a:srgbClr val="5E6570"/>
-              </a:solidFill>
-              <a:latin typeface="RCardnews W500" pitchFamily="34" charset="-127"/>
-              <a:ea typeface="RCardnews W500" pitchFamily="34" charset="-127"/>
-              <a:cs typeface="RCardnews W500" pitchFamily="34" charset="-127"/>
-            </a:endParaRPr>
-          </a:p>
-        </p:txBody>
-      </p:sp>
-      <p:sp>
-        <p:nvSpPr>
-          <p:cNvPr id="14" name="텍스트: 과한 압박이 반복되면 무릎뼈 속 압력이"/>
-          <p:cNvSpPr txBox="1"/>
-          <p:nvPr/>
-        </p:nvSpPr>
-        <p:spPr>
-          <a:xfrm>
-            <a:off x="1282005" y="9564731"/>
+            <a:off x="1282005" y="9986212"/>
             <a:ext cx="7722989" cy="504825"/>
           </a:xfrm>
           <a:prstGeom prst="rect">
@@ -818,13 +488,13 @@
       </p:sp>
       <p:sp>
         <p:nvSpPr>
-          <p:cNvPr id="15" name="텍스트: 올라 아플 수 있다고 추정합니다."/>
+          <p:cNvPr id="10" name="텍스트: 올라 아플 수 있다고 추정합니다."/>
           <p:cNvSpPr txBox="1"/>
           <p:nvPr/>
         </p:nvSpPr>
         <p:spPr>
           <a:xfrm>
-            <a:off x="1843832" y="10159746"/>
+            <a:off x="1843832" y="10581227"/>
             <a:ext cx="6599337" cy="504825"/>
           </a:xfrm>
           <a:prstGeom prst="rect">
@@ -877,14 +547,14 @@
       </p:sp>
       <p:sp>
         <p:nvSpPr>
-          <p:cNvPr id="16" name="텍스트: 아직 가설이며, 통증에는 신경이 예민해지는 "/>
+          <p:cNvPr id="11" name="텍스트: 아직 가설이며, 신경이 예민해지는 등 다른 "/>
           <p:cNvSpPr txBox="1"/>
           <p:nvPr/>
         </p:nvSpPr>
         <p:spPr>
           <a:xfrm>
-            <a:off x="1369368" y="10874014"/>
-            <a:ext cx="7548116" cy="409575"/>
+            <a:off x="508695" y="11276445"/>
+            <a:ext cx="9269462" cy="409575"/>
           </a:xfrm>
           <a:prstGeom prst="rect">
             <a:avLst/>
@@ -921,66 +591,7 @@
                 <a:ea typeface="RCardnews W500" pitchFamily="34" charset="-127"/>
                 <a:cs typeface="RCardnews W500" pitchFamily="34" charset="-127"/>
               </a:rPr>
-              <a:t xml:space="preserve">아직 가설이며, 통증에는 신경이 예민해지는 등</a:t>
-            </a:r>
-            <a:endParaRPr lang="ko-KR" altLang="en-US" sz="2700" b="0" i="0" spc="-54" kern="0" dirty="0">
-              <a:solidFill>
-                <a:srgbClr val="5E6570"/>
-              </a:solidFill>
-              <a:latin typeface="RCardnews W500" pitchFamily="34" charset="-127"/>
-              <a:ea typeface="RCardnews W500" pitchFamily="34" charset="-127"/>
-              <a:cs typeface="RCardnews W500" pitchFamily="34" charset="-127"/>
-            </a:endParaRPr>
-          </a:p>
-        </p:txBody>
-      </p:sp>
-      <p:sp>
-        <p:nvSpPr>
-          <p:cNvPr id="17" name="텍스트: 다른 요인도 함께 작용합니다"/>
-          <p:cNvSpPr txBox="1"/>
-          <p:nvPr/>
-        </p:nvSpPr>
-        <p:spPr>
-          <a:xfrm>
-            <a:off x="2586484" y="11353985"/>
-            <a:ext cx="5113883" cy="409575"/>
-          </a:xfrm>
-          <a:prstGeom prst="rect">
-            <a:avLst/>
-          </a:prstGeom>
-          <a:noFill/>
-          <a:ln>
-            <a:noFill/>
-          </a:ln>
-        </p:spPr>
-        <p:txBody>
-          <a:bodyPr vert="horz" wrap="none" lIns="0" tIns="0" rIns="0" bIns="0" rtlCol="0" anchor="ctr" anchorCtr="0">
-            <a:noAutofit/>
-          </a:bodyPr>
-          <a:lstStyle/>
-          <a:p>
-            <a:pPr algn="ctr">
-              <a:lnSpc>
-                <a:spcPct val="100000"/>
-              </a:lnSpc>
-              <a:spcBef>
-                <a:spcPts val="0"/>
-              </a:spcBef>
-              <a:spcAft>
-                <a:spcPts val="0"/>
-              </a:spcAft>
-              <a:buNone/>
-            </a:pPr>
-            <a:r>
-              <a:rPr lang="ko-KR" altLang="en-US" sz="2700" b="0" i="0" spc="-54" kern="0" dirty="0">
-                <a:solidFill>
-                  <a:srgbClr val="5E6570"/>
-                </a:solidFill>
-                <a:latin typeface="RCardnews W500" pitchFamily="34" charset="-127"/>
-                <a:ea typeface="RCardnews W500" pitchFamily="34" charset="-127"/>
-                <a:cs typeface="RCardnews W500" pitchFamily="34" charset="-127"/>
-              </a:rPr>
-              <a:t xml:space="preserve">다른 요인도 함께 작용합니다</a:t>
+              <a:t xml:space="preserve">아직 가설이며, 신경이 예민해지는 등 다른 요인도 있습니다</a:t>
             </a:r>
             <a:endParaRPr lang="ko-KR" altLang="en-US" sz="2700" b="0" i="0" spc="-54" kern="0" dirty="0">
               <a:solidFill>

</xml_diff>